<commit_message>
deck: white U1D logo on board cover (template + April report + presenter)
</commit_message>
<xml_diff>
--- a/board-template/2026-04/U1Dynamics_Board_Report_2026_04_PRESENTER.pptx
+++ b/board-template/2026-04/U1Dynamics_Board_Report_2026_04_PRESENTER.pptx
@@ -2489,45 +2489,6 @@
       </p:grpSpPr>
       <p:sp>
         <p:nvSpPr>
-          <p:cNvPr id="2" name="Text 0"/>
-          <p:cNvSpPr/>
-          <p:nvPr/>
-        </p:nvSpPr>
-        <p:spPr>
-          <a:xfrm>
-            <a:off x="713232" y="566928"/>
-            <a:ext cx="1965960" cy="292608"/>
-          </a:xfrm>
-          <a:prstGeom prst="rect">
-            <a:avLst/>
-          </a:prstGeom>
-          <a:noFill/>
-          <a:ln/>
-        </p:spPr>
-        <p:txBody>
-          <a:bodyPr wrap="square" lIns="0" tIns="0" rIns="0" bIns="0" rtlCol="0" anchor="ctr"/>
-          <a:lstStyle/>
-          <a:p>
-            <a:pPr indent="0" marL="0">
-              <a:buNone/>
-            </a:pPr>
-            <a:r>
-              <a:rPr lang="en-US" sz="1050" b="1" dirty="0">
-                <a:solidFill>
-                  <a:srgbClr val="FFFFFF"/>
-                </a:solidFill>
-                <a:latin typeface="Aptos" pitchFamily="34" charset="0"/>
-                <a:ea typeface="Aptos" pitchFamily="34" charset="-122"/>
-                <a:cs typeface="Aptos" pitchFamily="34" charset="-120"/>
-              </a:rPr>
-              <a:t>U1DYNAMICS</a:t>
-            </a:r>
-            <a:endParaRPr lang="en-US" sz="1050" dirty="0"/>
-          </a:p>
-        </p:txBody>
-      </p:sp>
-      <p:sp>
-        <p:nvSpPr>
           <p:cNvPr id="3" name="Shape 1"/>
           <p:cNvSpPr/>
           <p:nvPr/>
@@ -2548,6 +2509,10 @@
             <a:prstDash val="solid"/>
           </a:ln>
         </p:spPr>
+        <p:txBody>
+          <a:bodyPr/>
+          <a:p/>
+        </p:txBody>
       </p:sp>
       <p:sp>
         <p:nvSpPr>
@@ -2733,6 +2698,10 @@
             <a:prstDash val="solid"/>
           </a:ln>
         </p:spPr>
+        <p:txBody>
+          <a:bodyPr/>
+          <a:p/>
+        </p:txBody>
       </p:sp>
       <p:sp>
         <p:nvSpPr>
@@ -2853,6 +2822,10 @@
             <a:prstDash val="solid"/>
           </a:ln>
         </p:spPr>
+        <p:txBody>
+          <a:bodyPr/>
+          <a:p/>
+        </p:txBody>
       </p:sp>
       <p:sp>
         <p:nvSpPr>
@@ -2934,6 +2907,30 @@
           </a:p>
         </p:txBody>
       </p:sp>
+      <p:pic>
+        <p:nvPicPr>
+          <p:cNvPr id="14" name="Picture 13" descr="u1d-logo-white.png"/>
+          <p:cNvPicPr>
+            <a:picLocks noChangeAspect="1"/>
+          </p:cNvPicPr>
+          <p:nvPr/>
+        </p:nvPicPr>
+        <p:blipFill>
+          <a:blip r:embed="rId3"/>
+          <a:stretch>
+            <a:fillRect/>
+          </a:stretch>
+        </p:blipFill>
+        <p:spPr>
+          <a:xfrm>
+            <a:off x="713232" y="566928"/>
+            <a:ext cx="1554480" cy="1010412"/>
+          </a:xfrm>
+          <a:prstGeom prst="rect">
+            <a:avLst/>
+          </a:prstGeom>
+        </p:spPr>
+      </p:pic>
     </p:spTree>
   </p:cSld>
   <p:clrMapOvr>

</xml_diff>

<commit_message>
deck+guide: enrich April operations slide with Q1 narrative (Quarts bottleneck, supplier concentration, QA baseline); plain-text operator notes; template spec
</commit_message>
<xml_diff>
--- a/board-template/2026-04/U1Dynamics_Board_Report_2026_04_PRESENTER.pptx
+++ b/board-template/2026-04/U1Dynamics_Board_Report_2026_04_PRESENTER.pptx
@@ -1907,19 +1907,19 @@
           <a:lstStyle/>
           <a:p>
             <a:r>
-              <a:t>SAY (EN): Operationally April was clean. Produced 134,620 gal over 22 workdays, billed 103,453 — production ran ahead of billing, building ≈31K gal of inventory. Zero quality, supply, or line-down incidents. The board should not over-invest time here. The open item is inventory visibility — opening/closing, days of cover, dollar value. Ops/Finance to add that anchor before next distribution.</a:t>
+              <a:t>SAY (EN): Operationally, Q1 output rose 28% year over year — 374,866 gallons, averaging 127,372 a month and peaking at 141,506 in March; annualized that is about 1.5M gal/yr. The plant has slack in aggregate, but the Quarts line is at its real ceiling — ~1,208 gal/day, 96.5% availability — so it is our primary bottleneck for quart-format demand. Batch lines are efficient when they run. Two honest gaps: we depend on a single active oil supplier, Lubrimar, plus packaging vendors with lead-time and quality exposure; and at the start of this tenure there were no formal QA records, no finished-goods retains, and no OSHA log — one minor PPE incident. We are standing up measurement and QA now, and we have already secured an alternative drum supplier for Q2.</a:t>
             </a:r>
           </a:p>
           <a:p/>
           <a:p>
             <a:r>
-              <a:t>DIGA (ES): Abril fue limpio en operación. Producimos 134,620 gal en 22 días, facturamos 103,453 — la producción superó la facturación, acumulando ≈31K gal de inventario. Cero incidentes de calidad, suministro o paro. El Consejo no debe invertir mucho tiempo aquí. El punto abierto es la visibilidad de inventario — inicial/final, días de cobertura, valor en dólares. Operaciones/Finanzas agregan ese anclaje antes de la próxima distribución.</a:t>
+              <a:t>DIGA (ES): En lo operativo, la producción del Q1 subió 28% interanual — 374,866 galones, promedio de 127,372 al mes y pico de 141,506 en marzo; anualizado, cerca de 1.5M gal/año. La planta tiene holgura en agregado, pero la línea de Quarts está en su techo real — ~1,208 gal/día, 96.5% de disponibilidad — es nuestro cuello de botella primario para el formato quart. Las líneas batch son eficientes cuando operan. Dos brechas honestas: dependemos de un único proveedor activo de aceite, Lubrimar, más proveedores de envases con exposición de lead-time y calidad; y al inicio de esta gestión no había registros formales de QA, ni testigos de producto terminado, ni log de OSHA — un incidente menor de EPP. Estamos levantando la medición y el QA ahora, y ya aseguramos un proveedor alternativo de tambores para el Q2.</a:t>
             </a:r>
           </a:p>
           <a:p/>
           <a:p>
             <a:r>
-              <a:t>NUMBERS: produced 134,620 · billed 103,453 · build ≈31K · incidents 0.  ~1:00  ·  → Be clear what is board-grade.</a:t>
+              <a:t>NUMBERS: Q1 374,866 (+28.2%) · avg 127,372 · peak 141,506 · Quarts 96.5% · ~1.50M/yr.  ~1:00  ·  → What is board-grade tonight.</a:t>
             </a:r>
           </a:p>
         </p:txBody>
@@ -16450,7 +16450,7 @@
                 <a:ea typeface="Aptos Display" pitchFamily="34" charset="-122"/>
                 <a:cs typeface="Aptos Display" pitchFamily="34" charset="-120"/>
               </a:rPr>
-              <a:t>The plant is not the bottleneck; inventory visibility is the open item</a:t>
+              <a:t>Capacity is adequate overall; the Quarts line is the real constraint</a:t>
             </a:r>
             <a:endParaRPr lang="en-US" sz="2400" dirty="0"/>
           </a:p>
@@ -16491,7 +16491,7 @@
                 <a:ea typeface="Aptos" pitchFamily="34" charset="-122"/>
                 <a:cs typeface="Aptos" pitchFamily="34" charset="-120"/>
               </a:rPr>
-              <a:t>April production ran ahead of billing, supply was stable, and quality was clean.</a:t>
+              <a:t>Q1 output rose 28% year over year. The plant has slack in aggregate, but the Quarts line is at its ceiling — and there is no operational-measurement or QA baseline yet.</a:t>
             </a:r>
             <a:endParaRPr lang="en-US" sz="1070" dirty="0"/>
           </a:p>
@@ -16519,6 +16519,10 @@
             <a:prstDash val="solid"/>
           </a:ln>
         </p:spPr>
+        <p:txBody>
+          <a:bodyPr/>
+          <a:p/>
+        </p:txBody>
       </p:sp>
       <p:sp>
         <p:nvSpPr>
@@ -16546,6 +16550,10 @@
             <a:prstDash val="solid"/>
           </a:ln>
         </p:spPr>
+        <p:txBody>
+          <a:bodyPr/>
+          <a:p/>
+        </p:txBody>
       </p:sp>
       <p:sp>
         <p:nvSpPr>
@@ -16582,7 +16590,7 @@
                 <a:ea typeface="Aptos" pitchFamily="34" charset="-122"/>
                 <a:cs typeface="Aptos" pitchFamily="34" charset="-120"/>
               </a:rPr>
-              <a:t>PRODUCED · APRIL</a:t>
+              <a:t>Q1 PRODUCTION</a:t>
             </a:r>
             <a:endParaRPr lang="en-US" sz="540" dirty="0"/>
           </a:p>
@@ -16623,7 +16631,7 @@
                 <a:ea typeface="Aptos Display" pitchFamily="34" charset="-122"/>
                 <a:cs typeface="Aptos Display" pitchFamily="34" charset="-120"/>
               </a:rPr>
-              <a:t>134,620</a:t>
+              <a:t>374,866</a:t>
             </a:r>
             <a:endParaRPr lang="en-US" sz="2400" dirty="0"/>
           </a:p>
@@ -16664,7 +16672,7 @@
                 <a:ea typeface="Aptos" pitchFamily="34" charset="-122"/>
                 <a:cs typeface="Aptos" pitchFamily="34" charset="-120"/>
               </a:rPr>
-              <a:t>gallons across 22 workdays</a:t>
+              <a:t>gal · +28.2% vs Q1 2025</a:t>
             </a:r>
             <a:endParaRPr lang="en-US" sz="650" dirty="0"/>
           </a:p>
@@ -16696,6 +16704,10 @@
             <a:prstDash val="solid"/>
           </a:ln>
         </p:spPr>
+        <p:txBody>
+          <a:bodyPr/>
+          <a:p/>
+        </p:txBody>
       </p:sp>
       <p:sp>
         <p:nvSpPr>
@@ -16732,7 +16744,7 @@
                 <a:ea typeface="Aptos" pitchFamily="34" charset="-122"/>
                 <a:cs typeface="Aptos" pitchFamily="34" charset="-120"/>
               </a:rPr>
-              <a:t>BILLED · APRIL</a:t>
+              <a:t>MONTHLY AVG</a:t>
             </a:r>
             <a:endParaRPr lang="en-US" sz="540" dirty="0"/>
           </a:p>
@@ -16773,7 +16785,7 @@
                 <a:ea typeface="Aptos Display" pitchFamily="34" charset="-122"/>
                 <a:cs typeface="Aptos Display" pitchFamily="34" charset="-120"/>
               </a:rPr>
-              <a:t>103,453</a:t>
+              <a:t>127,372</a:t>
             </a:r>
             <a:endParaRPr lang="en-US" sz="2400" dirty="0"/>
           </a:p>
@@ -16814,7 +16826,7 @@
                 <a:ea typeface="Aptos" pitchFamily="34" charset="-122"/>
                 <a:cs typeface="Aptos" pitchFamily="34" charset="-120"/>
               </a:rPr>
-              <a:t>gallons</a:t>
+              <a:t>gal · peak Mar 141,506</a:t>
             </a:r>
             <a:endParaRPr lang="en-US" sz="650" dirty="0"/>
           </a:p>
@@ -16846,6 +16858,10 @@
             <a:prstDash val="solid"/>
           </a:ln>
         </p:spPr>
+        <p:txBody>
+          <a:bodyPr/>
+          <a:p/>
+        </p:txBody>
       </p:sp>
       <p:sp>
         <p:nvSpPr>
@@ -16882,7 +16898,7 @@
                 <a:ea typeface="Aptos" pitchFamily="34" charset="-122"/>
                 <a:cs typeface="Aptos" pitchFamily="34" charset="-120"/>
               </a:rPr>
-              <a:t>INVENTORY BUILD</a:t>
+              <a:t>QUARTS LINE</a:t>
             </a:r>
             <a:endParaRPr lang="en-US" sz="540" dirty="0"/>
           </a:p>
@@ -16923,7 +16939,7 @@
                 <a:ea typeface="Aptos Display" pitchFamily="34" charset="-122"/>
                 <a:cs typeface="Aptos Display" pitchFamily="34" charset="-120"/>
               </a:rPr>
-              <a:t>≈31K</a:t>
+              <a:t>96.5%</a:t>
             </a:r>
             <a:endParaRPr lang="en-US" sz="2400" dirty="0"/>
           </a:p>
@@ -16964,7 +16980,7 @@
                 <a:ea typeface="Aptos" pitchFamily="34" charset="-122"/>
                 <a:cs typeface="Aptos" pitchFamily="34" charset="-120"/>
               </a:rPr>
-              <a:t>gallons in April</a:t>
+              <a:t>availability · primary bottleneck</a:t>
             </a:r>
             <a:endParaRPr lang="en-US" sz="650" dirty="0"/>
           </a:p>
@@ -16996,6 +17012,10 @@
             <a:prstDash val="solid"/>
           </a:ln>
         </p:spPr>
+        <p:txBody>
+          <a:bodyPr/>
+          <a:p/>
+        </p:txBody>
       </p:sp>
       <p:sp>
         <p:nvSpPr>
@@ -17032,7 +17052,7 @@
                 <a:ea typeface="Aptos" pitchFamily="34" charset="-122"/>
                 <a:cs typeface="Aptos" pitchFamily="34" charset="-120"/>
               </a:rPr>
-              <a:t>INCIDENTS</a:t>
+              <a:t>RUN-RATE</a:t>
             </a:r>
             <a:endParaRPr lang="en-US" sz="540" dirty="0"/>
           </a:p>
@@ -17073,7 +17093,7 @@
                 <a:ea typeface="Aptos Display" pitchFamily="34" charset="-122"/>
                 <a:cs typeface="Aptos Display" pitchFamily="34" charset="-120"/>
               </a:rPr>
-              <a:t>0</a:t>
+              <a:t>~1.50M</a:t>
             </a:r>
             <a:endParaRPr lang="en-US" sz="2400" dirty="0"/>
           </a:p>
@@ -17114,7 +17134,7 @@
                 <a:ea typeface="Aptos" pitchFamily="34" charset="-122"/>
                 <a:cs typeface="Aptos" pitchFamily="34" charset="-120"/>
               </a:rPr>
-              <a:t>quality, supply, or line-down</a:t>
+              <a:t>gal/yr annualized (Q1 linear)</a:t>
             </a:r>
             <a:endParaRPr lang="en-US" sz="650" dirty="0"/>
           </a:p>
@@ -17146,6 +17166,10 @@
             <a:prstDash val="solid"/>
           </a:ln>
         </p:spPr>
+        <p:txBody>
+          <a:bodyPr/>
+          <a:p/>
+        </p:txBody>
       </p:sp>
       <p:sp>
         <p:nvSpPr>
@@ -17223,7 +17247,7 @@
                 <a:ea typeface="Aptos" pitchFamily="34" charset="-122"/>
                 <a:cs typeface="Aptos" pitchFamily="34" charset="-120"/>
               </a:rPr>
-              <a:t>Production exceeded billed volume. Plant capacity was not the constraint.</a:t>
+              <a:t>Quarts line at its real ceiling (~1,208 gal/day, 96.5% availability) — the primary bottleneck. Batch lines (5-Qt, Box Gal) efficient when running (68% / 48%). Drum/Tote nominal capacity needs recalibration.</a:t>
             </a:r>
             <a:endParaRPr lang="en-US" sz="840" dirty="0"/>
           </a:p>
@@ -17255,6 +17279,10 @@
             <a:prstDash val="solid"/>
           </a:ln>
         </p:spPr>
+        <p:txBody>
+          <a:bodyPr/>
+          <a:p/>
+        </p:txBody>
       </p:sp>
       <p:sp>
         <p:nvSpPr>
@@ -17332,7 +17360,7 @@
                 <a:ea typeface="Aptos" pitchFamily="34" charset="-122"/>
                 <a:cs typeface="Aptos" pitchFamily="34" charset="-120"/>
               </a:rPr>
-              <a:t>No material raw-material, additive, packaging, or freight disruption affected the period.</a:t>
+              <a:t>Single active oil supplier (Lubrimar) plus packaging vendors with critical lead-time and quality exposure (Gal/5-Qt bottles, drums). Alternative drum supplier secured for Q2.</a:t>
             </a:r>
             <a:endParaRPr lang="en-US" sz="840" dirty="0"/>
           </a:p>
@@ -17364,6 +17392,10 @@
             <a:prstDash val="solid"/>
           </a:ln>
         </p:spPr>
+        <p:txBody>
+          <a:bodyPr/>
+          <a:p/>
+        </p:txBody>
       </p:sp>
       <p:sp>
         <p:nvSpPr>
@@ -17441,7 +17473,7 @@
                 <a:ea typeface="Aptos" pitchFamily="34" charset="-122"/>
                 <a:cs typeface="Aptos" pitchFamily="34" charset="-120"/>
               </a:rPr>
-              <a:t>No quality incidents, batch holds, non-conformances, or customer quality complaints were recorded.</a:t>
+              <a:t>Baseline gap: no formal QA records or finished-goods retains at the start of this tenure, and no OSHA 300 log. One minor PPE incident (safety glasses). QA formats now in development.</a:t>
             </a:r>
             <a:endParaRPr lang="en-US" sz="840" dirty="0"/>
           </a:p>
@@ -17475,6 +17507,10 @@
             <a:prstDash val="solid"/>
           </a:ln>
         </p:spPr>
+        <p:txBody>
+          <a:bodyPr/>
+          <a:p/>
+        </p:txBody>
       </p:sp>
       <p:sp>
         <p:nvSpPr>
@@ -17552,7 +17588,7 @@
                 <a:ea typeface="Aptos" pitchFamily="34" charset="-122"/>
                 <a:cs typeface="Aptos" pitchFamily="34" charset="-120"/>
               </a:rPr>
-              <a:t>The board should not over-invest time in plant execution. The open operational item is inventory value, days of cover, and production-vs-billing clarity.</a:t>
+              <a:t>The constraint is the Quarts line, not the plant as a whole. The larger gap is the absence of operational measurement and a QA baseline — both are being stood up now. Neither is a reason to slow growth.</a:t>
             </a:r>
             <a:endParaRPr lang="en-US" sz="870" dirty="0"/>
           </a:p>
@@ -17584,6 +17620,10 @@
             <a:prstDash val="solid"/>
           </a:ln>
         </p:spPr>
+        <p:txBody>
+          <a:bodyPr/>
+          <a:p/>
+        </p:txBody>
       </p:sp>
       <p:sp>
         <p:nvSpPr>
@@ -17661,7 +17701,7 @@
                 <a:ea typeface="Aptos" pitchFamily="34" charset="-122"/>
                 <a:cs typeface="Aptos" pitchFamily="34" charset="-120"/>
               </a:rPr>
-              <a:t>Ops / Finance to add beginning inventory, ending inventory, days of cover, and $ value of movement before next distribution.</a:t>
+              <a:t>Approve Quarts-line modernization / conversion to Gal/5-Qt, and stand up downtime, fill-accuracy, QA, and inventory-reconciliation measurement before next distribution.</a:t>
             </a:r>
             <a:endParaRPr lang="en-US" sz="770" dirty="0"/>
           </a:p>
@@ -17689,6 +17729,10 @@
             <a:prstDash val="solid"/>
           </a:ln>
         </p:spPr>
+        <p:txBody>
+          <a:bodyPr/>
+          <a:p/>
+        </p:txBody>
       </p:sp>
       <p:sp>
         <p:nvSpPr>

</xml_diff>